<commit_message>
NightTwin: live browser demo, team and college details, narrated video tooling
- Static live demo on GitHub Pages; twin ported to JavaScript (dashboard/src/twin.js)
- Shareable demo states via URL (e.g. #patient/TP-001?snack=15&shift=90)
- Branding: NightTwin by Team TwinPulse, Newton School of Technology, Rishihood University
- README: live demo, video link, T1D rationale, brief compliance
- Narrated walkthrough generator (scripts/make_video.py); deck and architecture rebranded
</commit_message>
<xml_diff>
--- a/docs/TwinPulse_Presentation.pptx
+++ b/docs/TwinPulse_Presentation.pptx
@@ -124,24 +124,24 @@
   <p:extLst>
     <p:ext uri="{521415D9-36F7-43E2-AB2F-B90AF26B5E84}">
       <p14:sectionLst xmlns:p14="http://schemas.microsoft.com/office/powerpoint/2010/main">
-        <p14:section name="Opening" id="{d7144ac9-6258-0cc4-e547-ceaeef428249}">
+        <p14:section name="Opening" id="{570d1bd4-1b46-5737-1b19-6cb6b75486ef}">
           <p14:sldIdLst>
             <p14:sldId id="256"/>
             <p14:sldId id="257"/>
           </p14:sldIdLst>
         </p14:section>
-        <p14:section name="Problem" id="{a4ecb2b3-c7e7-697f-f99b-c44e8a9d73e3}">
+        <p14:section name="Problem" id="{8a44a676-8f67-cfe0-f914-400d8ccfeb75}">
           <p14:sldIdLst>
             <p14:sldId id="258"/>
           </p14:sldIdLst>
         </p14:section>
-        <p14:section name="Solution" id="{0ac8fc9b-0e3e-cc32-06f2-3887bd3dcb00}">
+        <p14:section name="Solution" id="{04ebf2eb-745d-3283-889f-513f4ab204ee}">
           <p14:sldIdLst>
             <p14:sldId id="259"/>
             <p14:sldId id="260"/>
           </p14:sldIdLst>
         </p14:section>
-        <p14:section name="How it works" id="{379cd14d-a219-a1e1-efa1-c1b6fb3b4799}">
+        <p14:section name="How it works" id="{d43a5dc9-2fa9-60e8-c8bb-03cbf39f4160}">
           <p14:sldIdLst>
             <p14:sldId id="261"/>
             <p14:sldId id="262"/>
@@ -149,27 +149,27 @@
             <p14:sldId id="264"/>
           </p14:sldIdLst>
         </p14:section>
-        <p14:section name="Evidence" id="{90928bcd-a5c2-d74d-f5fd-09146f920c0d}">
+        <p14:section name="Evidence" id="{cb892c76-93a5-a0c6-9006-ab82f3d57cf6}">
           <p14:sldIdLst>
             <p14:sldId id="265"/>
             <p14:sldId id="266"/>
             <p14:sldId id="267"/>
           </p14:sldIdLst>
         </p14:section>
-        <p14:section name="Product" id="{20a78388-2f65-a285-0684-16bb3c6b34fb}">
+        <p14:section name="Product" id="{0317264d-0e7b-5c83-bb43-e82e059e7191}">
           <p14:sldIdLst>
             <p14:sldId id="268"/>
             <p14:sldId id="269"/>
           </p14:sldIdLst>
         </p14:section>
-        <p14:section name="Trust and impact" id="{c9031fe7-e2e6-af53-7dbe-1da56a2cf7d1}">
+        <p14:section name="Trust and impact" id="{a915e873-17ac-2e72-8e58-f3fa13f1dffe}">
           <p14:sldIdLst>
             <p14:sldId id="270"/>
             <p14:sldId id="271"/>
             <p14:sldId id="272"/>
           </p14:sldIdLst>
         </p14:section>
-        <p14:section name="Close" id="{58c8256f-e6c6-9739-adf8-65448022035c}">
+        <p14:section name="Close" id="{8e02f34d-e71c-a45b-f119-7793820ab413}">
           <p14:sldIdLst>
             <p14:sldId id="273"/>
           </p14:sldIdLst>
@@ -673,7 +673,7 @@
               <c:strCache>
                 <c:ptCount val="1"/>
                 <c:pt idx="0">
-                  <c:v>TwinPulse</c:v>
+                  <c:v>NightTwin</c:v>
                 </c:pt>
               </c:strCache>
             </c:strRef>
@@ -2133,7 +2133,7 @@
           <a:p>
             <a:r>
               <a:rPr lang="en-US" dirty="0"/>
-              <a:t>Hello, we are Team TwinPulse. Our project is a digital twin that lives the night first: before a child with type 1 diabetes goes to sleep, her twin rehearses tonight 500 times, so the doctor can see the danger and fix it before it happens.</a:t>
+              <a:t>Hello, we are Team TwinPulse from Newton School of Technology, Rishihood University. Our project, NightTwin, is a digital twin that lives the night first: before a child with type 1 diabetes goes to sleep, her twin rehearses tonight 500 times, so the doctor can see the danger and fix it before it happens.</a:t>
             </a:r>
             <a:endParaRPr lang="en-US" dirty="0"/>
           </a:p>
@@ -2397,7 +2397,7 @@
           <a:p>
             <a:r>
               <a:rPr lang="en-US" dirty="0"/>
-              <a:t>Without nightly CGM we cannot guard every night. So TwinPulse helps share scarce sensors fairly. On real patients, one week of sensor data ranked who would have the most night lows later: 42 percent of later nights for the top third, versus 10 percent for the bottom third.</a:t>
+              <a:t>Without nightly CGM we cannot guard every night. So NightTwin helps share scarce sensors fairly. On real patients, one week of sensor data ranked who would have the most night lows later: 42 percent of later nights for the top third, versus 10 percent for the bottom third.</a:t>
             </a:r>
             <a:endParaRPr lang="en-US" dirty="0"/>
           </a:p>
@@ -2573,7 +2573,7 @@
           <a:p>
             <a:r>
               <a:rPr lang="en-US" dirty="0"/>
-              <a:t>TwinPulse is designed for India: alerts in the family's language, voice calls for feature phones, models of the human insulin our programmes supply, Indian routines like late dinners and evening cricket, and FHIR records ready for ABDM.</a:t>
+              <a:t>NightTwin is designed for India: alerts in the family's language, voice calls for feature phones, models of the human insulin our programmes supply, Indian routines like late dinners and evening cricket, and FHIR records ready for ABDM.</a:t>
             </a:r>
             <a:endParaRPr lang="en-US" dirty="0"/>
           </a:p>
@@ -2661,7 +2661,7 @@
           <a:p>
             <a:r>
               <a:rPr lang="en-US" dirty="0"/>
-              <a:t>Children's health data needs extra care. Under the DPDP Act, children's data needs verifiable parental consent, and the 2025 Rules exempt clinics providing health services, so TwinPulse is deployed by the clinic. The doctor stays in charge of every decision.</a:t>
+              <a:t>Children's health data needs extra care. Under the DPDP Act, children's data needs verifiable parental consent, and the 2025 Rules exempt clinics providing health services, so NightTwin is deployed by the clinic. The doctor stays in charge of every decision.</a:t>
             </a:r>
             <a:endParaRPr lang="en-US" dirty="0"/>
           </a:p>
@@ -2925,7 +2925,7 @@
           <a:p>
             <a:r>
               <a:rPr lang="en-US" dirty="0"/>
-              <a:t>In 1970, NASA rehearsed the Apollo 13 rescue on a twin of the spacecraft before trying it for real. TwinPulse does the same for a child's night. Thank you.</a:t>
+              <a:t>In 1970, NASA rehearsed the Apollo 13 rescue on a twin of the spacecraft before trying it for real. NightTwin does the same for a child's night. Thank you.</a:t>
             </a:r>
             <a:endParaRPr lang="en-US" dirty="0"/>
           </a:p>
@@ -3189,7 +3189,7 @@
           <a:p>
             <a:r>
               <a:rPr lang="en-US" dirty="0"/>
-              <a:t>TwinPulse does three things. It learns each child as a personal physiology model. At 9 PM it lives tonight 500 times, so the doctor sees the risk and rehearses fixes. And for children with a CGM, it guards the real night, warning about an hour before a low.</a:t>
+              <a:t>NightTwin does three things. It learns each child as a personal physiology model. At 9 PM it lives tonight 500 times, so the doctor sees the risk and rehearses fixes. And for children with a CGM, it guards the real night, warning about an hour before a low.</a:t>
             </a:r>
             <a:endParaRPr lang="en-US" dirty="0"/>
           </a:p>
@@ -3910,7 +3910,7 @@
                   <a:schemeClr val="tx2"/>
                 </a:solidFill>
               </a:rPr>
-              <a:t>TwinPulse · The twin lives the night first</a:t>
+              <a:t>NightTwin by Team TwinPulse · Newton School of Technology, Rishihood University</a:t>
             </a:r>
             <a:endParaRPr lang="en-US" sz="1000" dirty="0"/>
           </a:p>
@@ -4065,7 +4065,7 @@
                   <a:schemeClr val="accent5"/>
                 </a:solidFill>
               </a:rPr>
-              <a:t>TwinPulse · The twin lives the night first</a:t>
+              <a:t>NightTwin by Team TwinPulse · Newton School of Technology, Rishihood University</a:t>
             </a:r>
             <a:endParaRPr lang="en-US" sz="1000" dirty="0"/>
           </a:p>
@@ -4475,7 +4475,7 @@
         <p:spPr>
           <a:xfrm>
             <a:off x="640080" y="1417320"/>
-            <a:ext cx="7315200" cy="365760"/>
+            <a:ext cx="8229600" cy="365760"/>
           </a:xfrm>
           <a:prstGeom prst="rect">
             <a:avLst/>
@@ -4496,7 +4496,7 @@
                   <a:schemeClr val="accent2"/>
                 </a:solidFill>
               </a:rPr>
-              <a:t>TWINPULSE · DIGITAL TWIN CHALLENGE 2026</a:t>
+              <a:t>TEAM TWINPULSE · HAPPIEST HEALTH DIGITAL TWIN CHALLENGE 2026</a:t>
             </a:r>
             <a:endParaRPr lang="en-US" sz="1400" dirty="0"/>
           </a:p>
@@ -4537,7 +4537,7 @@
                 <a:ea typeface="Cambria" pitchFamily="34" charset="-122"/>
                 <a:cs typeface="Cambria" pitchFamily="34" charset="-120"/>
               </a:rPr>
-              <a:t>The twin lives the night first</a:t>
+              <a:t>NightTwin: the twin lives the night first</a:t>
             </a:r>
             <a:endParaRPr lang="en-US" sz="4600" dirty="0"/>
           </a:p>
@@ -4611,7 +4611,7 @@
                   <a:schemeClr val="bg1"/>
                 </a:solidFill>
               </a:rPr>
-              <a:t>Team TwinPulse</a:t>
+              <a:t>Team TwinPulse · Newton School of Technology, Rishihood University</a:t>
             </a:r>
             <a:endParaRPr lang="en-US" sz="1600" dirty="0"/>
           </a:p>
@@ -6578,7 +6578,7 @@
                   <a:schemeClr val="tx2"/>
                 </a:solidFill>
               </a:rPr>
-              <a:t>Section 9: verifiable parental consent; no tracking or behavioural monitoring of children. The DPDP Rules 2025 (Fourth Schedule) exempt clinics and healthcare professionals for health services to the child, so TwinPulse is deployed by the clinic as data fiduciary, with consent recorded anyway.</a:t>
+              <a:t>Section 9: verifiable parental consent; no tracking or behavioural monitoring of children. The DPDP Rules 2025 (Fourth Schedule) exempt clinics and healthcare professionals for health services to the child, so NightTwin is deployed by the clinic as data fiduciary, with consent recorded anyway.</a:t>
             </a:r>
             <a:endParaRPr lang="en-US" sz="1400" dirty="0"/>
           </a:p>
@@ -8065,7 +8065,7 @@
                   <a:schemeClr val="bg1"/>
                 </a:solidFill>
               </a:rPr>
-              <a:t>Team TwinPulse</a:t>
+              <a:t>Team TwinPulse · Newton School of Technology, Rishihood University</a:t>
             </a:r>
             <a:endParaRPr lang="en-US" sz="1600" dirty="0"/>
           </a:p>
@@ -8101,7 +8101,7 @@
                   <a:schemeClr val="accent5"/>
                 </a:solidFill>
               </a:rPr>
-              <a:t>Code, data sources and results: see the GitHub README</a:t>
+              <a:t>Live demo: manangilhotra.github.io/TwinPulse_NewtonSchoolOfTechnology_RishihoodUniversity</a:t>
             </a:r>
             <a:endParaRPr lang="en-US" sz="1400" dirty="0"/>
           </a:p>
@@ -9210,7 +9210,7 @@
                 <a:ea typeface="Cambria" pitchFamily="34" charset="-122"/>
                 <a:cs typeface="Cambria" pitchFamily="34" charset="-120"/>
               </a:rPr>
-              <a:t>TwinPulse: learn the child, live tonight first, guard the real night</a:t>
+              <a:t>NightTwin: learn the child, live tonight first, guard the real night</a:t>
             </a:r>
             <a:endParaRPr lang="en-US" sz="3200" dirty="0"/>
           </a:p>
@@ -11252,7 +11252,7 @@
       </p:sp>
       <p:pic>
         <p:nvPicPr>
-          <p:cNvPr id="3" name="image-53" descr="TwinPulse architecture: data, preparation, models, API, users, trust layer">    </p:cNvPr>
+          <p:cNvPr id="3" name="image-53" descr="NightTwin architecture: data, preparation, models, API, users, trust layer">    </p:cNvPr>
           <p:cNvPicPr>
             <a:picLocks noChangeAspect="1"/>
           </p:cNvPicPr>

</xml_diff>

<commit_message>
Add team members: Manan Gilhotra (leader), Manas Saxena
</commit_message>
<xml_diff>
--- a/docs/TwinPulse_Presentation.pptx
+++ b/docs/TwinPulse_Presentation.pptx
@@ -124,24 +124,24 @@
   <p:extLst>
     <p:ext uri="{521415D9-36F7-43E2-AB2F-B90AF26B5E84}">
       <p14:sectionLst xmlns:p14="http://schemas.microsoft.com/office/powerpoint/2010/main">
-        <p14:section name="Opening" id="{570d1bd4-1b46-5737-1b19-6cb6b75486ef}">
+        <p14:section name="Opening" id="{f20d744a-7a25-d824-8eea-39bee868937a}">
           <p14:sldIdLst>
             <p14:sldId id="256"/>
             <p14:sldId id="257"/>
           </p14:sldIdLst>
         </p14:section>
-        <p14:section name="Problem" id="{8a44a676-8f67-cfe0-f914-400d8ccfeb75}">
+        <p14:section name="Problem" id="{16076383-5a87-ad2d-6621-139d25d7e3a7}">
           <p14:sldIdLst>
             <p14:sldId id="258"/>
           </p14:sldIdLst>
         </p14:section>
-        <p14:section name="Solution" id="{04ebf2eb-745d-3283-889f-513f4ab204ee}">
+        <p14:section name="Solution" id="{d97b26b7-3cf5-27ed-823f-0df35ace214f}">
           <p14:sldIdLst>
             <p14:sldId id="259"/>
             <p14:sldId id="260"/>
           </p14:sldIdLst>
         </p14:section>
-        <p14:section name="How it works" id="{d43a5dc9-2fa9-60e8-c8bb-03cbf39f4160}">
+        <p14:section name="How it works" id="{77e27d47-e82b-43dd-45f2-1e2ec5160d08}">
           <p14:sldIdLst>
             <p14:sldId id="261"/>
             <p14:sldId id="262"/>
@@ -149,27 +149,27 @@
             <p14:sldId id="264"/>
           </p14:sldIdLst>
         </p14:section>
-        <p14:section name="Evidence" id="{cb892c76-93a5-a0c6-9006-ab82f3d57cf6}">
+        <p14:section name="Evidence" id="{1b54fe38-fd94-d9c3-e950-7b2ecda45835}">
           <p14:sldIdLst>
             <p14:sldId id="265"/>
             <p14:sldId id="266"/>
             <p14:sldId id="267"/>
           </p14:sldIdLst>
         </p14:section>
-        <p14:section name="Product" id="{0317264d-0e7b-5c83-bb43-e82e059e7191}">
+        <p14:section name="Product" id="{22bb4e7f-cefe-e533-c0a6-59b06de5e2ef}">
           <p14:sldIdLst>
             <p14:sldId id="268"/>
             <p14:sldId id="269"/>
           </p14:sldIdLst>
         </p14:section>
-        <p14:section name="Trust and impact" id="{a915e873-17ac-2e72-8e58-f3fa13f1dffe}">
+        <p14:section name="Trust and impact" id="{166656c8-c74b-ae1c-6a03-35c31bdd4624}">
           <p14:sldIdLst>
             <p14:sldId id="270"/>
             <p14:sldId id="271"/>
             <p14:sldId id="272"/>
           </p14:sldIdLst>
         </p14:section>
-        <p14:section name="Close" id="{8e02f34d-e71c-a45b-f119-7793820ab413}">
+        <p14:section name="Close" id="{38b74ee5-d759-ab19-f901-e8f6c18b9316}">
           <p14:sldIdLst>
             <p14:sldId id="273"/>
           </p14:sldIdLst>
@@ -4589,8 +4589,8 @@
         </p:nvSpPr>
         <p:spPr>
           <a:xfrm>
-            <a:off x="640080" y="5669280"/>
-            <a:ext cx="7315200" cy="365760"/>
+            <a:off x="640080" y="5440680"/>
+            <a:ext cx="8229600" cy="365760"/>
           </a:xfrm>
           <a:prstGeom prst="rect">
             <a:avLst/>
@@ -4619,7 +4619,43 @@
       </p:sp>
       <p:sp>
         <p:nvSpPr>
-          <p:cNvPr id="6" name="moon"/>
+          <p:cNvPr id="6" name="text-3"/>
+          <p:cNvSpPr txBox="1"/>
+          <p:nvPr/>
+        </p:nvSpPr>
+        <p:spPr>
+          <a:xfrm>
+            <a:off x="640080" y="5852160"/>
+            <a:ext cx="8229600" cy="365760"/>
+          </a:xfrm>
+          <a:prstGeom prst="rect">
+            <a:avLst/>
+          </a:prstGeom>
+          <a:noFill/>
+          <a:ln/>
+        </p:spPr>
+        <p:txBody>
+          <a:bodyPr wrap="square" lIns="0" tIns="0" rIns="0" bIns="0" rtlCol="0" anchor="t"/>
+          <a:lstStyle/>
+          <a:p>
+            <a:pPr indent="0" marL="0">
+              <a:buNone/>
+            </a:pPr>
+            <a:r>
+              <a:rPr lang="en-US" sz="1400" dirty="0">
+                <a:solidFill>
+                  <a:schemeClr val="accent5"/>
+                </a:solidFill>
+              </a:rPr>
+              <a:t>Manan Gilhotra (team leader) · Manas Saxena</a:t>
+            </a:r>
+            <a:endParaRPr lang="en-US" sz="1400" dirty="0"/>
+          </a:p>
+        </p:txBody>
+      </p:sp>
+      <p:sp>
+        <p:nvSpPr>
+          <p:cNvPr id="7" name="moon"/>
           <p:cNvSpPr/>
           <p:nvPr/>
         </p:nvSpPr>
@@ -4644,7 +4680,7 @@
       </p:sp>
       <p:sp>
         <p:nvSpPr>
-          <p:cNvPr id="7" name="moon-shadow"/>
+          <p:cNvPr id="8" name="moon-shadow"/>
           <p:cNvSpPr/>
           <p:nvPr/>
         </p:nvSpPr>
@@ -4669,7 +4705,7 @@
       </p:sp>
       <p:sp>
         <p:nvSpPr>
-          <p:cNvPr id="8" name="text-3"/>
+          <p:cNvPr id="9" name="text-4"/>
           <p:cNvSpPr txBox="1"/>
           <p:nvPr/>
         </p:nvSpPr>
@@ -4831,7 +4867,7 @@
       </p:graphicFrame>
       <p:sp>
         <p:nvSpPr>
-          <p:cNvPr id="5" name="text-69"/>
+          <p:cNvPr id="5" name="text-70"/>
           <p:cNvSpPr txBox="1"/>
           <p:nvPr/>
         </p:nvSpPr>
@@ -4994,7 +5030,7 @@
       </p:graphicFrame>
       <p:sp>
         <p:nvSpPr>
-          <p:cNvPr id="4" name="list-70"/>
+          <p:cNvPr id="4" name="list-71"/>
           <p:cNvSpPr txBox="1"/>
           <p:nvPr/>
         </p:nvSpPr>
@@ -5215,7 +5251,7 @@
       </p:graphicFrame>
       <p:sp>
         <p:nvSpPr>
-          <p:cNvPr id="4" name="text-71"/>
+          <p:cNvPr id="4" name="text-72"/>
           <p:cNvSpPr txBox="1"/>
           <p:nvPr/>
         </p:nvSpPr>
@@ -5254,7 +5290,7 @@
       </p:sp>
       <p:sp>
         <p:nvSpPr>
-          <p:cNvPr id="5" name="text-72"/>
+          <p:cNvPr id="5" name="text-73"/>
           <p:cNvSpPr txBox="1"/>
           <p:nvPr/>
         </p:nvSpPr>
@@ -5290,7 +5326,7 @@
       </p:sp>
       <p:sp>
         <p:nvSpPr>
-          <p:cNvPr id="6" name="text-73"/>
+          <p:cNvPr id="6" name="text-74"/>
           <p:cNvSpPr txBox="1"/>
           <p:nvPr/>
         </p:nvSpPr>
@@ -5329,7 +5365,7 @@
       </p:sp>
       <p:sp>
         <p:nvSpPr>
-          <p:cNvPr id="7" name="text-74"/>
+          <p:cNvPr id="7" name="text-75"/>
           <p:cNvSpPr txBox="1"/>
           <p:nvPr/>
         </p:nvSpPr>
@@ -5365,7 +5401,7 @@
       </p:sp>
       <p:sp>
         <p:nvSpPr>
-          <p:cNvPr id="8" name="text-75"/>
+          <p:cNvPr id="8" name="text-76"/>
           <p:cNvSpPr txBox="1"/>
           <p:nvPr/>
         </p:nvSpPr>
@@ -5512,7 +5548,7 @@
       </p:sp>
       <p:pic>
         <p:nvPicPr>
-          <p:cNvPr id="3" name="image-76" descr="Tonight Board ranking children by risk">    </p:cNvPr>
+          <p:cNvPr id="3" name="image-77" descr="Tonight Board ranking children by risk">    </p:cNvPr>
           <p:cNvPicPr>
             <a:picLocks noChangeAspect="1"/>
           </p:cNvPicPr>
@@ -5536,7 +5572,7 @@
       </p:pic>
       <p:sp>
         <p:nvSpPr>
-          <p:cNvPr id="4" name="list-77"/>
+          <p:cNvPr id="4" name="list-78"/>
           <p:cNvSpPr txBox="1"/>
           <p:nvPr/>
         </p:nvSpPr>
@@ -5759,7 +5795,7 @@
       </p:sp>
       <p:pic>
         <p:nvPicPr>
-          <p:cNvPr id="3" name="image-78" descr="Night guard replay with a Malayalam voice alert">    </p:cNvPr>
+          <p:cNvPr id="3" name="image-79" descr="Night guard replay with a Malayalam voice alert">    </p:cNvPr>
           <p:cNvPicPr>
             <a:picLocks noChangeAspect="1"/>
           </p:cNvPicPr>
@@ -5783,7 +5819,7 @@
       </p:pic>
       <p:sp>
         <p:nvSpPr>
-          <p:cNvPr id="4" name="badge-79"/>
+          <p:cNvPr id="4" name="badge-80"/>
           <p:cNvSpPr/>
           <p:nvPr/>
         </p:nvSpPr>
@@ -5808,7 +5844,7 @@
       </p:sp>
       <p:sp>
         <p:nvSpPr>
-          <p:cNvPr id="5" name="badge-label-80"/>
+          <p:cNvPr id="5" name="badge-label-81"/>
           <p:cNvSpPr txBox="1"/>
           <p:nvPr/>
         </p:nvSpPr>
@@ -5844,7 +5880,7 @@
       </p:sp>
       <p:sp>
         <p:nvSpPr>
-          <p:cNvPr id="6" name="text-81"/>
+          <p:cNvPr id="6" name="text-82"/>
           <p:cNvSpPr txBox="1"/>
           <p:nvPr/>
         </p:nvSpPr>
@@ -5880,7 +5916,7 @@
       </p:sp>
       <p:sp>
         <p:nvSpPr>
-          <p:cNvPr id="7" name="text-82"/>
+          <p:cNvPr id="7" name="text-83"/>
           <p:cNvSpPr txBox="1"/>
           <p:nvPr/>
         </p:nvSpPr>
@@ -5916,7 +5952,7 @@
       </p:sp>
       <p:sp>
         <p:nvSpPr>
-          <p:cNvPr id="8" name="badge-83"/>
+          <p:cNvPr id="8" name="badge-84"/>
           <p:cNvSpPr/>
           <p:nvPr/>
         </p:nvSpPr>
@@ -5941,7 +5977,7 @@
       </p:sp>
       <p:sp>
         <p:nvSpPr>
-          <p:cNvPr id="9" name="badge-label-84"/>
+          <p:cNvPr id="9" name="badge-label-85"/>
           <p:cNvSpPr txBox="1"/>
           <p:nvPr/>
         </p:nvSpPr>
@@ -5977,7 +6013,7 @@
       </p:sp>
       <p:sp>
         <p:nvSpPr>
-          <p:cNvPr id="10" name="text-85"/>
+          <p:cNvPr id="10" name="text-86"/>
           <p:cNvSpPr txBox="1"/>
           <p:nvPr/>
         </p:nvSpPr>
@@ -6013,7 +6049,7 @@
       </p:sp>
       <p:sp>
         <p:nvSpPr>
-          <p:cNvPr id="11" name="text-86"/>
+          <p:cNvPr id="11" name="text-87"/>
           <p:cNvSpPr txBox="1"/>
           <p:nvPr/>
         </p:nvSpPr>
@@ -6049,7 +6085,7 @@
       </p:sp>
       <p:sp>
         <p:nvSpPr>
-          <p:cNvPr id="12" name="badge-87"/>
+          <p:cNvPr id="12" name="badge-88"/>
           <p:cNvSpPr/>
           <p:nvPr/>
         </p:nvSpPr>
@@ -6074,7 +6110,7 @@
       </p:sp>
       <p:sp>
         <p:nvSpPr>
-          <p:cNvPr id="13" name="badge-label-88"/>
+          <p:cNvPr id="13" name="badge-label-89"/>
           <p:cNvSpPr txBox="1"/>
           <p:nvPr/>
         </p:nvSpPr>
@@ -6110,7 +6146,7 @@
       </p:sp>
       <p:sp>
         <p:nvSpPr>
-          <p:cNvPr id="14" name="text-89"/>
+          <p:cNvPr id="14" name="text-90"/>
           <p:cNvSpPr txBox="1"/>
           <p:nvPr/>
         </p:nvSpPr>
@@ -6146,7 +6182,7 @@
       </p:sp>
       <p:sp>
         <p:nvSpPr>
-          <p:cNvPr id="15" name="text-90"/>
+          <p:cNvPr id="15" name="text-91"/>
           <p:cNvSpPr txBox="1"/>
           <p:nvPr/>
         </p:nvSpPr>
@@ -6182,7 +6218,7 @@
       </p:sp>
       <p:sp>
         <p:nvSpPr>
-          <p:cNvPr id="16" name="badge-91"/>
+          <p:cNvPr id="16" name="badge-92"/>
           <p:cNvSpPr/>
           <p:nvPr/>
         </p:nvSpPr>
@@ -6207,7 +6243,7 @@
       </p:sp>
       <p:sp>
         <p:nvSpPr>
-          <p:cNvPr id="17" name="badge-label-92"/>
+          <p:cNvPr id="17" name="badge-label-93"/>
           <p:cNvSpPr txBox="1"/>
           <p:nvPr/>
         </p:nvSpPr>
@@ -6243,7 +6279,7 @@
       </p:sp>
       <p:sp>
         <p:nvSpPr>
-          <p:cNvPr id="18" name="text-93"/>
+          <p:cNvPr id="18" name="text-94"/>
           <p:cNvSpPr txBox="1"/>
           <p:nvPr/>
         </p:nvSpPr>
@@ -6279,7 +6315,7 @@
       </p:sp>
       <p:sp>
         <p:nvSpPr>
-          <p:cNvPr id="19" name="text-94"/>
+          <p:cNvPr id="19" name="text-95"/>
           <p:cNvSpPr txBox="1"/>
           <p:nvPr/>
         </p:nvSpPr>
@@ -6426,7 +6462,7 @@
       </p:sp>
       <p:sp>
         <p:nvSpPr>
-          <p:cNvPr id="3" name="card-95"/>
+          <p:cNvPr id="3" name="card-96"/>
           <p:cNvSpPr/>
           <p:nvPr/>
         </p:nvSpPr>
@@ -6453,7 +6489,7 @@
       </p:sp>
       <p:sp>
         <p:nvSpPr>
-          <p:cNvPr id="4" name="badge-96"/>
+          <p:cNvPr id="4" name="badge-97"/>
           <p:cNvSpPr/>
           <p:nvPr/>
         </p:nvSpPr>
@@ -6478,7 +6514,7 @@
       </p:sp>
       <p:sp>
         <p:nvSpPr>
-          <p:cNvPr id="5" name="badge-label-97"/>
+          <p:cNvPr id="5" name="badge-label-98"/>
           <p:cNvSpPr txBox="1"/>
           <p:nvPr/>
         </p:nvSpPr>
@@ -6514,7 +6550,7 @@
       </p:sp>
       <p:sp>
         <p:nvSpPr>
-          <p:cNvPr id="6" name="text-98"/>
+          <p:cNvPr id="6" name="text-99"/>
           <p:cNvSpPr txBox="1"/>
           <p:nvPr/>
         </p:nvSpPr>
@@ -6550,7 +6586,7 @@
       </p:sp>
       <p:sp>
         <p:nvSpPr>
-          <p:cNvPr id="7" name="text-99"/>
+          <p:cNvPr id="7" name="text-100"/>
           <p:cNvSpPr txBox="1"/>
           <p:nvPr/>
         </p:nvSpPr>
@@ -6586,7 +6622,7 @@
       </p:sp>
       <p:sp>
         <p:nvSpPr>
-          <p:cNvPr id="8" name="card-100"/>
+          <p:cNvPr id="8" name="card-101"/>
           <p:cNvSpPr/>
           <p:nvPr/>
         </p:nvSpPr>
@@ -6613,7 +6649,7 @@
       </p:sp>
       <p:sp>
         <p:nvSpPr>
-          <p:cNvPr id="9" name="badge-101"/>
+          <p:cNvPr id="9" name="badge-102"/>
           <p:cNvSpPr/>
           <p:nvPr/>
         </p:nvSpPr>
@@ -6638,7 +6674,7 @@
       </p:sp>
       <p:sp>
         <p:nvSpPr>
-          <p:cNvPr id="10" name="badge-label-102"/>
+          <p:cNvPr id="10" name="badge-label-103"/>
           <p:cNvSpPr txBox="1"/>
           <p:nvPr/>
         </p:nvSpPr>
@@ -6674,7 +6710,7 @@
       </p:sp>
       <p:sp>
         <p:nvSpPr>
-          <p:cNvPr id="11" name="text-103"/>
+          <p:cNvPr id="11" name="text-104"/>
           <p:cNvSpPr txBox="1"/>
           <p:nvPr/>
         </p:nvSpPr>
@@ -6710,7 +6746,7 @@
       </p:sp>
       <p:sp>
         <p:nvSpPr>
-          <p:cNvPr id="12" name="text-104"/>
+          <p:cNvPr id="12" name="text-105"/>
           <p:cNvSpPr txBox="1"/>
           <p:nvPr/>
         </p:nvSpPr>
@@ -6746,7 +6782,7 @@
       </p:sp>
       <p:sp>
         <p:nvSpPr>
-          <p:cNvPr id="13" name="card-105"/>
+          <p:cNvPr id="13" name="card-106"/>
           <p:cNvSpPr/>
           <p:nvPr/>
         </p:nvSpPr>
@@ -6773,7 +6809,7 @@
       </p:sp>
       <p:sp>
         <p:nvSpPr>
-          <p:cNvPr id="14" name="badge-106"/>
+          <p:cNvPr id="14" name="badge-107"/>
           <p:cNvSpPr/>
           <p:nvPr/>
         </p:nvSpPr>
@@ -6798,7 +6834,7 @@
       </p:sp>
       <p:sp>
         <p:nvSpPr>
-          <p:cNvPr id="15" name="badge-label-107"/>
+          <p:cNvPr id="15" name="badge-label-108"/>
           <p:cNvSpPr txBox="1"/>
           <p:nvPr/>
         </p:nvSpPr>
@@ -6834,7 +6870,7 @@
       </p:sp>
       <p:sp>
         <p:nvSpPr>
-          <p:cNvPr id="16" name="text-108"/>
+          <p:cNvPr id="16" name="text-109"/>
           <p:cNvSpPr txBox="1"/>
           <p:nvPr/>
         </p:nvSpPr>
@@ -6870,7 +6906,7 @@
       </p:sp>
       <p:sp>
         <p:nvSpPr>
-          <p:cNvPr id="17" name="text-109"/>
+          <p:cNvPr id="17" name="text-110"/>
           <p:cNvSpPr txBox="1"/>
           <p:nvPr/>
         </p:nvSpPr>
@@ -7017,7 +7053,7 @@
       </p:sp>
       <p:sp>
         <p:nvSpPr>
-          <p:cNvPr id="3" name="text-110"/>
+          <p:cNvPr id="3" name="text-111"/>
           <p:cNvSpPr txBox="1"/>
           <p:nvPr/>
         </p:nvSpPr>
@@ -7056,7 +7092,7 @@
       </p:sp>
       <p:sp>
         <p:nvSpPr>
-          <p:cNvPr id="4" name="text-111"/>
+          <p:cNvPr id="4" name="text-112"/>
           <p:cNvSpPr txBox="1"/>
           <p:nvPr/>
         </p:nvSpPr>
@@ -7092,7 +7128,7 @@
       </p:sp>
       <p:sp>
         <p:nvSpPr>
-          <p:cNvPr id="5" name="text-112"/>
+          <p:cNvPr id="5" name="text-113"/>
           <p:cNvSpPr txBox="1"/>
           <p:nvPr/>
         </p:nvSpPr>
@@ -7131,7 +7167,7 @@
       </p:sp>
       <p:sp>
         <p:nvSpPr>
-          <p:cNvPr id="6" name="text-113"/>
+          <p:cNvPr id="6" name="text-114"/>
           <p:cNvSpPr txBox="1"/>
           <p:nvPr/>
         </p:nvSpPr>
@@ -7167,7 +7203,7 @@
       </p:sp>
       <p:sp>
         <p:nvSpPr>
-          <p:cNvPr id="7" name="text-114"/>
+          <p:cNvPr id="7" name="text-115"/>
           <p:cNvSpPr txBox="1"/>
           <p:nvPr/>
         </p:nvSpPr>
@@ -7206,7 +7242,7 @@
       </p:sp>
       <p:sp>
         <p:nvSpPr>
-          <p:cNvPr id="8" name="text-115"/>
+          <p:cNvPr id="8" name="text-116"/>
           <p:cNvSpPr txBox="1"/>
           <p:nvPr/>
         </p:nvSpPr>
@@ -7242,7 +7278,7 @@
       </p:sp>
       <p:sp>
         <p:nvSpPr>
-          <p:cNvPr id="9" name="card-116"/>
+          <p:cNvPr id="9" name="card-117"/>
           <p:cNvSpPr/>
           <p:nvPr/>
         </p:nvSpPr>
@@ -7269,7 +7305,7 @@
       </p:sp>
       <p:sp>
         <p:nvSpPr>
-          <p:cNvPr id="10" name="text-117"/>
+          <p:cNvPr id="10" name="text-118"/>
           <p:cNvSpPr txBox="1"/>
           <p:nvPr/>
         </p:nvSpPr>
@@ -7305,7 +7341,7 @@
       </p:sp>
       <p:sp>
         <p:nvSpPr>
-          <p:cNvPr id="11" name="list-118"/>
+          <p:cNvPr id="11" name="list-119"/>
           <p:cNvSpPr txBox="1"/>
           <p:nvPr/>
         </p:nvSpPr>
@@ -7492,7 +7528,7 @@
       </p:sp>
       <p:sp>
         <p:nvSpPr>
-          <p:cNvPr id="3" name="card-119"/>
+          <p:cNvPr id="3" name="card-120"/>
           <p:cNvSpPr/>
           <p:nvPr/>
         </p:nvSpPr>
@@ -7519,7 +7555,7 @@
       </p:sp>
       <p:sp>
         <p:nvSpPr>
-          <p:cNvPr id="4" name="text-120"/>
+          <p:cNvPr id="4" name="text-121"/>
           <p:cNvSpPr txBox="1"/>
           <p:nvPr/>
         </p:nvSpPr>
@@ -7555,7 +7591,7 @@
       </p:sp>
       <p:sp>
         <p:nvSpPr>
-          <p:cNvPr id="5" name="text-121"/>
+          <p:cNvPr id="5" name="text-122"/>
           <p:cNvSpPr txBox="1"/>
           <p:nvPr/>
         </p:nvSpPr>
@@ -7591,7 +7627,7 @@
       </p:sp>
       <p:sp>
         <p:nvSpPr>
-          <p:cNvPr id="6" name="card-122"/>
+          <p:cNvPr id="6" name="card-123"/>
           <p:cNvSpPr/>
           <p:nvPr/>
         </p:nvSpPr>
@@ -7618,7 +7654,7 @@
       </p:sp>
       <p:sp>
         <p:nvSpPr>
-          <p:cNvPr id="7" name="text-123"/>
+          <p:cNvPr id="7" name="text-124"/>
           <p:cNvSpPr txBox="1"/>
           <p:nvPr/>
         </p:nvSpPr>
@@ -7654,7 +7690,7 @@
       </p:sp>
       <p:sp>
         <p:nvSpPr>
-          <p:cNvPr id="8" name="text-124"/>
+          <p:cNvPr id="8" name="text-125"/>
           <p:cNvSpPr txBox="1"/>
           <p:nvPr/>
         </p:nvSpPr>
@@ -7690,7 +7726,7 @@
       </p:sp>
       <p:sp>
         <p:nvSpPr>
-          <p:cNvPr id="9" name="card-125"/>
+          <p:cNvPr id="9" name="card-126"/>
           <p:cNvSpPr/>
           <p:nvPr/>
         </p:nvSpPr>
@@ -7717,7 +7753,7 @@
       </p:sp>
       <p:sp>
         <p:nvSpPr>
-          <p:cNvPr id="10" name="text-126"/>
+          <p:cNvPr id="10" name="text-127"/>
           <p:cNvSpPr txBox="1"/>
           <p:nvPr/>
         </p:nvSpPr>
@@ -7753,7 +7789,7 @@
       </p:sp>
       <p:sp>
         <p:nvSpPr>
-          <p:cNvPr id="11" name="text-127"/>
+          <p:cNvPr id="11" name="text-128"/>
           <p:cNvSpPr txBox="1"/>
           <p:nvPr/>
         </p:nvSpPr>
@@ -7789,7 +7825,7 @@
       </p:sp>
       <p:sp>
         <p:nvSpPr>
-          <p:cNvPr id="12" name="card-128"/>
+          <p:cNvPr id="12" name="card-129"/>
           <p:cNvSpPr/>
           <p:nvPr/>
         </p:nvSpPr>
@@ -7816,7 +7852,7 @@
       </p:sp>
       <p:sp>
         <p:nvSpPr>
-          <p:cNvPr id="13" name="text-129"/>
+          <p:cNvPr id="13" name="text-130"/>
           <p:cNvSpPr txBox="1"/>
           <p:nvPr/>
         </p:nvSpPr>
@@ -7852,7 +7888,7 @@
       </p:sp>
       <p:sp>
         <p:nvSpPr>
-          <p:cNvPr id="14" name="text-130"/>
+          <p:cNvPr id="14" name="text-131"/>
           <p:cNvSpPr txBox="1"/>
           <p:nvPr/>
         </p:nvSpPr>
@@ -8037,14 +8073,14 @@
       </p:sp>
       <p:sp>
         <p:nvSpPr>
-          <p:cNvPr id="4" name="text-131"/>
+          <p:cNvPr id="4" name="text-132"/>
           <p:cNvSpPr txBox="1"/>
           <p:nvPr/>
         </p:nvSpPr>
         <p:spPr>
           <a:xfrm>
-            <a:off x="640080" y="5212080"/>
-            <a:ext cx="7772400" cy="365760"/>
+            <a:off x="640080" y="4846320"/>
+            <a:ext cx="7772400" cy="685800"/>
           </a:xfrm>
           <a:prstGeom prst="rect">
             <a:avLst/>
@@ -8069,11 +8105,25 @@
             </a:r>
             <a:endParaRPr lang="en-US" sz="1600" dirty="0"/>
           </a:p>
-        </p:txBody>
-      </p:sp>
-      <p:sp>
-        <p:nvSpPr>
-          <p:cNvPr id="5" name="text-132"/>
+          <a:p>
+            <a:pPr indent="0" marL="0">
+              <a:buNone/>
+            </a:pPr>
+            <a:r>
+              <a:rPr lang="en-US" sz="1600" dirty="0">
+                <a:solidFill>
+                  <a:schemeClr val="bg1"/>
+                </a:solidFill>
+              </a:rPr>
+              <a:t>Manan Gilhotra (team leader) · Manas Saxena</a:t>
+            </a:r>
+            <a:endParaRPr lang="en-US" sz="1600" dirty="0"/>
+          </a:p>
+        </p:txBody>
+      </p:sp>
+      <p:sp>
+        <p:nvSpPr>
+          <p:cNvPr id="5" name="text-133"/>
           <p:cNvSpPr txBox="1"/>
           <p:nvPr/>
         </p:nvSpPr>
@@ -8225,7 +8275,7 @@
       </p:sp>
       <p:sp>
         <p:nvSpPr>
-          <p:cNvPr id="3" name="card-4"/>
+          <p:cNvPr id="3" name="card-5"/>
           <p:cNvSpPr/>
           <p:nvPr/>
         </p:nvSpPr>
@@ -8252,7 +8302,7 @@
       </p:sp>
       <p:sp>
         <p:nvSpPr>
-          <p:cNvPr id="4" name="text-5"/>
+          <p:cNvPr id="4" name="text-6"/>
           <p:cNvSpPr txBox="1"/>
           <p:nvPr/>
         </p:nvSpPr>
@@ -8291,7 +8341,7 @@
       </p:sp>
       <p:sp>
         <p:nvSpPr>
-          <p:cNvPr id="5" name="text-6"/>
+          <p:cNvPr id="5" name="text-7"/>
           <p:cNvSpPr txBox="1"/>
           <p:nvPr/>
         </p:nvSpPr>
@@ -8327,7 +8377,7 @@
       </p:sp>
       <p:sp>
         <p:nvSpPr>
-          <p:cNvPr id="6" name="text-7"/>
+          <p:cNvPr id="6" name="text-8"/>
           <p:cNvSpPr txBox="1"/>
           <p:nvPr/>
         </p:nvSpPr>
@@ -8366,7 +8416,7 @@
       </p:sp>
       <p:sp>
         <p:nvSpPr>
-          <p:cNvPr id="7" name="text-8"/>
+          <p:cNvPr id="7" name="text-9"/>
           <p:cNvSpPr txBox="1"/>
           <p:nvPr/>
         </p:nvSpPr>
@@ -8402,7 +8452,7 @@
       </p:sp>
       <p:sp>
         <p:nvSpPr>
-          <p:cNvPr id="8" name="text-9"/>
+          <p:cNvPr id="8" name="text-10"/>
           <p:cNvSpPr txBox="1"/>
           <p:nvPr/>
         </p:nvSpPr>
@@ -8441,7 +8491,7 @@
       </p:sp>
       <p:sp>
         <p:nvSpPr>
-          <p:cNvPr id="9" name="text-10"/>
+          <p:cNvPr id="9" name="text-11"/>
           <p:cNvSpPr txBox="1"/>
           <p:nvPr/>
         </p:nvSpPr>
@@ -8477,7 +8527,7 @@
       </p:sp>
       <p:sp>
         <p:nvSpPr>
-          <p:cNvPr id="10" name="text-11"/>
+          <p:cNvPr id="10" name="text-12"/>
           <p:cNvSpPr txBox="1"/>
           <p:nvPr/>
         </p:nvSpPr>
@@ -8516,7 +8566,7 @@
       </p:sp>
       <p:sp>
         <p:nvSpPr>
-          <p:cNvPr id="11" name="text-12"/>
+          <p:cNvPr id="11" name="text-13"/>
           <p:cNvSpPr txBox="1"/>
           <p:nvPr/>
         </p:nvSpPr>
@@ -8663,7 +8713,7 @@
       </p:sp>
       <p:sp>
         <p:nvSpPr>
-          <p:cNvPr id="3" name="card-13"/>
+          <p:cNvPr id="3" name="card-14"/>
           <p:cNvSpPr/>
           <p:nvPr/>
         </p:nvSpPr>
@@ -8690,7 +8740,7 @@
       </p:sp>
       <p:sp>
         <p:nvSpPr>
-          <p:cNvPr id="4" name="text-14"/>
+          <p:cNvPr id="4" name="text-15"/>
           <p:cNvSpPr txBox="1"/>
           <p:nvPr/>
         </p:nvSpPr>
@@ -8729,7 +8779,7 @@
       </p:sp>
       <p:sp>
         <p:nvSpPr>
-          <p:cNvPr id="5" name="text-15"/>
+          <p:cNvPr id="5" name="text-16"/>
           <p:cNvSpPr txBox="1"/>
           <p:nvPr/>
         </p:nvSpPr>
@@ -8765,7 +8815,7 @@
       </p:sp>
       <p:sp>
         <p:nvSpPr>
-          <p:cNvPr id="6" name="card-16"/>
+          <p:cNvPr id="6" name="card-17"/>
           <p:cNvSpPr/>
           <p:nvPr/>
         </p:nvSpPr>
@@ -8792,7 +8842,7 @@
       </p:sp>
       <p:sp>
         <p:nvSpPr>
-          <p:cNvPr id="7" name="text-17"/>
+          <p:cNvPr id="7" name="text-18"/>
           <p:cNvSpPr txBox="1"/>
           <p:nvPr/>
         </p:nvSpPr>
@@ -8831,7 +8881,7 @@
       </p:sp>
       <p:sp>
         <p:nvSpPr>
-          <p:cNvPr id="8" name="text-18"/>
+          <p:cNvPr id="8" name="text-19"/>
           <p:cNvSpPr txBox="1"/>
           <p:nvPr/>
         </p:nvSpPr>
@@ -8867,7 +8917,7 @@
       </p:sp>
       <p:sp>
         <p:nvSpPr>
-          <p:cNvPr id="9" name="card-19"/>
+          <p:cNvPr id="9" name="card-20"/>
           <p:cNvSpPr/>
           <p:nvPr/>
         </p:nvSpPr>
@@ -8894,7 +8944,7 @@
       </p:sp>
       <p:sp>
         <p:nvSpPr>
-          <p:cNvPr id="10" name="text-20"/>
+          <p:cNvPr id="10" name="text-21"/>
           <p:cNvSpPr txBox="1"/>
           <p:nvPr/>
         </p:nvSpPr>
@@ -8933,7 +8983,7 @@
       </p:sp>
       <p:sp>
         <p:nvSpPr>
-          <p:cNvPr id="11" name="text-21"/>
+          <p:cNvPr id="11" name="text-22"/>
           <p:cNvSpPr txBox="1"/>
           <p:nvPr/>
         </p:nvSpPr>
@@ -8969,7 +9019,7 @@
       </p:sp>
       <p:sp>
         <p:nvSpPr>
-          <p:cNvPr id="12" name="card-22"/>
+          <p:cNvPr id="12" name="card-23"/>
           <p:cNvSpPr/>
           <p:nvPr/>
         </p:nvSpPr>
@@ -8996,7 +9046,7 @@
       </p:sp>
       <p:sp>
         <p:nvSpPr>
-          <p:cNvPr id="13" name="text-23"/>
+          <p:cNvPr id="13" name="text-24"/>
           <p:cNvSpPr txBox="1"/>
           <p:nvPr/>
         </p:nvSpPr>
@@ -9035,7 +9085,7 @@
       </p:sp>
       <p:sp>
         <p:nvSpPr>
-          <p:cNvPr id="14" name="text-24"/>
+          <p:cNvPr id="14" name="text-25"/>
           <p:cNvSpPr txBox="1"/>
           <p:nvPr/>
         </p:nvSpPr>
@@ -9071,7 +9121,7 @@
       </p:sp>
       <p:sp>
         <p:nvSpPr>
-          <p:cNvPr id="15" name="text-25"/>
+          <p:cNvPr id="15" name="text-26"/>
           <p:cNvSpPr txBox="1"/>
           <p:nvPr/>
         </p:nvSpPr>
@@ -9218,7 +9268,7 @@
       </p:sp>
       <p:sp>
         <p:nvSpPr>
-          <p:cNvPr id="3" name="card-26"/>
+          <p:cNvPr id="3" name="card-27"/>
           <p:cNvSpPr/>
           <p:nvPr/>
         </p:nvSpPr>
@@ -9245,7 +9295,7 @@
       </p:sp>
       <p:sp>
         <p:nvSpPr>
-          <p:cNvPr id="4" name="badge-27"/>
+          <p:cNvPr id="4" name="badge-28"/>
           <p:cNvSpPr/>
           <p:nvPr/>
         </p:nvSpPr>
@@ -9270,7 +9320,7 @@
       </p:sp>
       <p:sp>
         <p:nvSpPr>
-          <p:cNvPr id="5" name="badge-label-28"/>
+          <p:cNvPr id="5" name="badge-label-29"/>
           <p:cNvSpPr txBox="1"/>
           <p:nvPr/>
         </p:nvSpPr>
@@ -9306,7 +9356,7 @@
       </p:sp>
       <p:sp>
         <p:nvSpPr>
-          <p:cNvPr id="6" name="text-29"/>
+          <p:cNvPr id="6" name="text-30"/>
           <p:cNvSpPr txBox="1"/>
           <p:nvPr/>
         </p:nvSpPr>
@@ -9345,7 +9395,7 @@
       </p:sp>
       <p:sp>
         <p:nvSpPr>
-          <p:cNvPr id="7" name="text-30"/>
+          <p:cNvPr id="7" name="text-31"/>
           <p:cNvSpPr txBox="1"/>
           <p:nvPr/>
         </p:nvSpPr>
@@ -9381,7 +9431,7 @@
       </p:sp>
       <p:sp>
         <p:nvSpPr>
-          <p:cNvPr id="8" name="card-31"/>
+          <p:cNvPr id="8" name="card-32"/>
           <p:cNvSpPr/>
           <p:nvPr/>
         </p:nvSpPr>
@@ -9408,7 +9458,7 @@
       </p:sp>
       <p:sp>
         <p:nvSpPr>
-          <p:cNvPr id="9" name="badge-32"/>
+          <p:cNvPr id="9" name="badge-33"/>
           <p:cNvSpPr/>
           <p:nvPr/>
         </p:nvSpPr>
@@ -9433,7 +9483,7 @@
       </p:sp>
       <p:sp>
         <p:nvSpPr>
-          <p:cNvPr id="10" name="badge-label-33"/>
+          <p:cNvPr id="10" name="badge-label-34"/>
           <p:cNvSpPr txBox="1"/>
           <p:nvPr/>
         </p:nvSpPr>
@@ -9469,7 +9519,7 @@
       </p:sp>
       <p:sp>
         <p:nvSpPr>
-          <p:cNvPr id="11" name="text-34"/>
+          <p:cNvPr id="11" name="text-35"/>
           <p:cNvSpPr txBox="1"/>
           <p:nvPr/>
         </p:nvSpPr>
@@ -9508,7 +9558,7 @@
       </p:sp>
       <p:sp>
         <p:nvSpPr>
-          <p:cNvPr id="12" name="text-35"/>
+          <p:cNvPr id="12" name="text-36"/>
           <p:cNvSpPr txBox="1"/>
           <p:nvPr/>
         </p:nvSpPr>
@@ -9544,7 +9594,7 @@
       </p:sp>
       <p:sp>
         <p:nvSpPr>
-          <p:cNvPr id="13" name="card-36"/>
+          <p:cNvPr id="13" name="card-37"/>
           <p:cNvSpPr/>
           <p:nvPr/>
         </p:nvSpPr>
@@ -9571,7 +9621,7 @@
       </p:sp>
       <p:sp>
         <p:nvSpPr>
-          <p:cNvPr id="14" name="badge-37"/>
+          <p:cNvPr id="14" name="badge-38"/>
           <p:cNvSpPr/>
           <p:nvPr/>
         </p:nvSpPr>
@@ -9596,7 +9646,7 @@
       </p:sp>
       <p:sp>
         <p:nvSpPr>
-          <p:cNvPr id="15" name="badge-label-38"/>
+          <p:cNvPr id="15" name="badge-label-39"/>
           <p:cNvSpPr txBox="1"/>
           <p:nvPr/>
         </p:nvSpPr>
@@ -9632,7 +9682,7 @@
       </p:sp>
       <p:sp>
         <p:nvSpPr>
-          <p:cNvPr id="16" name="text-39"/>
+          <p:cNvPr id="16" name="text-40"/>
           <p:cNvSpPr txBox="1"/>
           <p:nvPr/>
         </p:nvSpPr>
@@ -9671,7 +9721,7 @@
       </p:sp>
       <p:sp>
         <p:nvSpPr>
-          <p:cNvPr id="17" name="text-40"/>
+          <p:cNvPr id="17" name="text-41"/>
           <p:cNvSpPr txBox="1"/>
           <p:nvPr/>
         </p:nvSpPr>
@@ -9707,7 +9757,7 @@
       </p:sp>
       <p:sp>
         <p:nvSpPr>
-          <p:cNvPr id="18" name="text-41"/>
+          <p:cNvPr id="18" name="text-42"/>
           <p:cNvSpPr txBox="1"/>
           <p:nvPr/>
         </p:nvSpPr>
@@ -9854,7 +9904,7 @@
       </p:sp>
       <p:sp>
         <p:nvSpPr>
-          <p:cNvPr id="3" name="card-42"/>
+          <p:cNvPr id="3" name="card-43"/>
           <p:cNvSpPr/>
           <p:nvPr/>
         </p:nvSpPr>
@@ -9881,7 +9931,7 @@
       </p:sp>
       <p:sp>
         <p:nvSpPr>
-          <p:cNvPr id="4" name="text-43"/>
+          <p:cNvPr id="4" name="text-44"/>
           <p:cNvSpPr txBox="1"/>
           <p:nvPr/>
         </p:nvSpPr>
@@ -9917,7 +9967,7 @@
       </p:sp>
       <p:sp>
         <p:nvSpPr>
-          <p:cNvPr id="5" name="list-44"/>
+          <p:cNvPr id="5" name="list-45"/>
           <p:cNvSpPr txBox="1"/>
           <p:nvPr/>
         </p:nvSpPr>
@@ -10011,7 +10061,7 @@
       </p:sp>
       <p:sp>
         <p:nvSpPr>
-          <p:cNvPr id="6" name="text-45"/>
+          <p:cNvPr id="6" name="text-46"/>
           <p:cNvSpPr txBox="1"/>
           <p:nvPr/>
         </p:nvSpPr>
@@ -10047,7 +10097,7 @@
       </p:sp>
       <p:sp>
         <p:nvSpPr>
-          <p:cNvPr id="7" name="card-46"/>
+          <p:cNvPr id="7" name="card-47"/>
           <p:cNvSpPr/>
           <p:nvPr/>
         </p:nvSpPr>
@@ -10074,7 +10124,7 @@
       </p:sp>
       <p:sp>
         <p:nvSpPr>
-          <p:cNvPr id="8" name="text-47"/>
+          <p:cNvPr id="8" name="text-48"/>
           <p:cNvSpPr txBox="1"/>
           <p:nvPr/>
         </p:nvSpPr>
@@ -10110,7 +10160,7 @@
       </p:sp>
       <p:sp>
         <p:nvSpPr>
-          <p:cNvPr id="9" name="list-48"/>
+          <p:cNvPr id="9" name="list-49"/>
           <p:cNvSpPr txBox="1"/>
           <p:nvPr/>
         </p:nvSpPr>
@@ -10204,7 +10254,7 @@
       </p:sp>
       <p:sp>
         <p:nvSpPr>
-          <p:cNvPr id="10" name="text-49"/>
+          <p:cNvPr id="10" name="text-50"/>
           <p:cNvSpPr txBox="1"/>
           <p:nvPr/>
         </p:nvSpPr>
@@ -10240,7 +10290,7 @@
       </p:sp>
       <p:sp>
         <p:nvSpPr>
-          <p:cNvPr id="11" name="card-50"/>
+          <p:cNvPr id="11" name="card-51"/>
           <p:cNvSpPr/>
           <p:nvPr/>
         </p:nvSpPr>
@@ -10267,7 +10317,7 @@
       </p:sp>
       <p:sp>
         <p:nvSpPr>
-          <p:cNvPr id="12" name="text-51"/>
+          <p:cNvPr id="12" name="text-52"/>
           <p:cNvSpPr txBox="1"/>
           <p:nvPr/>
         </p:nvSpPr>
@@ -10303,7 +10353,7 @@
       </p:sp>
       <p:sp>
         <p:nvSpPr>
-          <p:cNvPr id="13" name="list-52"/>
+          <p:cNvPr id="13" name="list-53"/>
           <p:cNvSpPr txBox="1"/>
           <p:nvPr/>
         </p:nvSpPr>
@@ -11252,7 +11302,7 @@
       </p:sp>
       <p:pic>
         <p:nvPicPr>
-          <p:cNvPr id="3" name="image-53" descr="NightTwin architecture: data, preparation, models, API, users, trust layer">    </p:cNvPr>
+          <p:cNvPr id="3" name="image-54" descr="NightTwin architecture: data, preparation, models, API, users, trust layer">    </p:cNvPr>
           <p:cNvPicPr>
             <a:picLocks noChangeAspect="1"/>
           </p:cNvPicPr>
@@ -11387,7 +11437,7 @@
       </p:sp>
       <p:pic>
         <p:nvPicPr>
-          <p:cNvPr id="3" name="image-54" descr="Ananya's night simulated 500 times; risk falls from 58% to 14% with a plan">    </p:cNvPr>
+          <p:cNvPr id="3" name="image-55" descr="Ananya's night simulated 500 times; risk falls from 58% to 14% with a plan">    </p:cNvPr>
           <p:cNvPicPr>
             <a:picLocks noChangeAspect="1"/>
           </p:cNvPicPr>
@@ -11411,7 +11461,7 @@
       </p:pic>
       <p:sp>
         <p:nvSpPr>
-          <p:cNvPr id="4" name="list-55"/>
+          <p:cNvPr id="4" name="list-56"/>
           <p:cNvSpPr txBox="1"/>
           <p:nvPr/>
         </p:nvSpPr>
@@ -11505,7 +11555,7 @@
       </p:sp>
       <p:sp>
         <p:nvSpPr>
-          <p:cNvPr id="5" name="text-56"/>
+          <p:cNvPr id="5" name="text-57"/>
           <p:cNvSpPr txBox="1"/>
           <p:nvPr/>
         </p:nvSpPr>
@@ -11652,7 +11702,7 @@
       </p:sp>
       <p:pic>
         <p:nvPicPr>
-          <p:cNvPr id="3" name="image-57" descr="Ananya's twin page in the dashboard">    </p:cNvPr>
+          <p:cNvPr id="3" name="image-58" descr="Ananya's twin page in the dashboard">    </p:cNvPr>
           <p:cNvPicPr>
             <a:picLocks noChangeAspect="1"/>
           </p:cNvPicPr>
@@ -11676,7 +11726,7 @@
       </p:pic>
       <p:sp>
         <p:nvSpPr>
-          <p:cNvPr id="4" name="text-58"/>
+          <p:cNvPr id="4" name="text-59"/>
           <p:cNvSpPr txBox="1"/>
           <p:nvPr/>
         </p:nvSpPr>
@@ -11715,7 +11765,7 @@
       </p:sp>
       <p:sp>
         <p:nvSpPr>
-          <p:cNvPr id="5" name="text-59"/>
+          <p:cNvPr id="5" name="text-60"/>
           <p:cNvSpPr txBox="1"/>
           <p:nvPr/>
         </p:nvSpPr>
@@ -11751,7 +11801,7 @@
       </p:sp>
       <p:sp>
         <p:nvSpPr>
-          <p:cNvPr id="6" name="list-60"/>
+          <p:cNvPr id="6" name="list-61"/>
           <p:cNvSpPr txBox="1"/>
           <p:nvPr/>
         </p:nvSpPr>
@@ -11956,7 +12006,7 @@
       </p:sp>
       <p:pic>
         <p:nvPicPr>
-          <p:cNvPr id="3" name="image-61" descr="Arjun's night replay: alert before the low">    </p:cNvPr>
+          <p:cNvPr id="3" name="image-62" descr="Arjun's night replay: alert before the low">    </p:cNvPr>
           <p:cNvPicPr>
             <a:picLocks noChangeAspect="1"/>
           </p:cNvPicPr>
@@ -11980,7 +12030,7 @@
       </p:pic>
       <p:sp>
         <p:nvSpPr>
-          <p:cNvPr id="4" name="text-62"/>
+          <p:cNvPr id="4" name="text-63"/>
           <p:cNvSpPr txBox="1"/>
           <p:nvPr/>
         </p:nvSpPr>
@@ -12019,7 +12069,7 @@
       </p:sp>
       <p:sp>
         <p:nvSpPr>
-          <p:cNvPr id="5" name="text-63"/>
+          <p:cNvPr id="5" name="text-64"/>
           <p:cNvSpPr txBox="1"/>
           <p:nvPr/>
         </p:nvSpPr>
@@ -12055,7 +12105,7 @@
       </p:sp>
       <p:sp>
         <p:nvSpPr>
-          <p:cNvPr id="6" name="text-64"/>
+          <p:cNvPr id="6" name="text-65"/>
           <p:cNvSpPr txBox="1"/>
           <p:nvPr/>
         </p:nvSpPr>
@@ -12094,7 +12144,7 @@
       </p:sp>
       <p:sp>
         <p:nvSpPr>
-          <p:cNvPr id="7" name="text-65"/>
+          <p:cNvPr id="7" name="text-66"/>
           <p:cNvSpPr txBox="1"/>
           <p:nvPr/>
         </p:nvSpPr>
@@ -12130,7 +12180,7 @@
       </p:sp>
       <p:sp>
         <p:nvSpPr>
-          <p:cNvPr id="8" name="text-66"/>
+          <p:cNvPr id="8" name="text-67"/>
           <p:cNvSpPr txBox="1"/>
           <p:nvPr/>
         </p:nvSpPr>
@@ -12169,7 +12219,7 @@
       </p:sp>
       <p:sp>
         <p:nvSpPr>
-          <p:cNvPr id="9" name="text-67"/>
+          <p:cNvPr id="9" name="text-68"/>
           <p:cNvSpPr txBox="1"/>
           <p:nvPr/>
         </p:nvSpPr>
@@ -12205,7 +12255,7 @@
       </p:sp>
       <p:sp>
         <p:nvSpPr>
-          <p:cNvPr id="10" name="text-68"/>
+          <p:cNvPr id="10" name="text-69"/>
           <p:cNvSpPr txBox="1"/>
           <p:nvPr/>
         </p:nvSpPr>

</xml_diff>

<commit_message>
NightTwin logo, redesigned navbar and UI polish; emotional jury script with screen cues
- Logo (crescent + pulse) in navbar, favicon, deck and README
- Navbar: wordmark left, pill navigation centre, status pills right; responsive
- v3 design layer: typography, cards, tables, buttons, focus states, icons, footer
- scripts/video_script.py: single source for docs/VIDEO_SCRIPT.md and the narrated video
</commit_message>
<xml_diff>
--- a/docs/TwinPulse_Presentation.pptx
+++ b/docs/TwinPulse_Presentation.pptx
@@ -124,24 +124,24 @@
   <p:extLst>
     <p:ext uri="{521415D9-36F7-43E2-AB2F-B90AF26B5E84}">
       <p14:sectionLst xmlns:p14="http://schemas.microsoft.com/office/powerpoint/2010/main">
-        <p14:section name="Opening" id="{f20d744a-7a25-d824-8eea-39bee868937a}">
+        <p14:section name="Opening" id="{f4944502-0dcf-a543-b4c2-76da9721d6a7}">
           <p14:sldIdLst>
             <p14:sldId id="256"/>
             <p14:sldId id="257"/>
           </p14:sldIdLst>
         </p14:section>
-        <p14:section name="Problem" id="{16076383-5a87-ad2d-6621-139d25d7e3a7}">
+        <p14:section name="Problem" id="{8221603f-7e8a-e776-2c38-45dd0be19cab}">
           <p14:sldIdLst>
             <p14:sldId id="258"/>
           </p14:sldIdLst>
         </p14:section>
-        <p14:section name="Solution" id="{d97b26b7-3cf5-27ed-823f-0df35ace214f}">
+        <p14:section name="Solution" id="{359636aa-4dee-40ee-468d-8f0e193dc70a}">
           <p14:sldIdLst>
             <p14:sldId id="259"/>
             <p14:sldId id="260"/>
           </p14:sldIdLst>
         </p14:section>
-        <p14:section name="How it works" id="{77e27d47-e82b-43dd-45f2-1e2ec5160d08}">
+        <p14:section name="How it works" id="{89ee4d2d-f961-698d-dfcd-aef78d22b26e}">
           <p14:sldIdLst>
             <p14:sldId id="261"/>
             <p14:sldId id="262"/>
@@ -149,27 +149,27 @@
             <p14:sldId id="264"/>
           </p14:sldIdLst>
         </p14:section>
-        <p14:section name="Evidence" id="{1b54fe38-fd94-d9c3-e950-7b2ecda45835}">
+        <p14:section name="Evidence" id="{41c3631e-af68-db21-da4c-c459621a44dc}">
           <p14:sldIdLst>
             <p14:sldId id="265"/>
             <p14:sldId id="266"/>
             <p14:sldId id="267"/>
           </p14:sldIdLst>
         </p14:section>
-        <p14:section name="Product" id="{22bb4e7f-cefe-e533-c0a6-59b06de5e2ef}">
+        <p14:section name="Product" id="{33b120f5-1613-a353-f81d-586dda12904a}">
           <p14:sldIdLst>
             <p14:sldId id="268"/>
             <p14:sldId id="269"/>
           </p14:sldIdLst>
         </p14:section>
-        <p14:section name="Trust and impact" id="{166656c8-c74b-ae1c-6a03-35c31bdd4624}">
+        <p14:section name="Trust and impact" id="{21ec2651-577d-ef30-9b40-5b510f0c8a24}">
           <p14:sldIdLst>
             <p14:sldId id="270"/>
             <p14:sldId id="271"/>
             <p14:sldId id="272"/>
           </p14:sldIdLst>
         </p14:section>
-        <p14:section name="Close" id="{38b74ee5-d759-ab19-f901-e8f6c18b9316}">
+        <p14:section name="Close" id="{4ef8ceae-aaf4-701e-a6d0-e6be6b4f94ff}">
           <p14:sldIdLst>
             <p14:sldId id="273"/>
           </p14:sldIdLst>
@@ -3880,15 +3880,39 @@
           </a:p>
         </p:txBody>
       </p:sp>
-      <p:sp>
-        <p:nvSpPr>
-          <p:cNvPr id="3" name="Text 0"/>
+      <p:pic>
+        <p:nvPicPr>
+          <p:cNvPr id="3" name="Image 0" descr="/Users/manangilhotra010/Happiest Health HACK/TwinPulse_NewtonSchoolOfTechnology_RishihoodUniversity/docs/brand/nighttwin_logo.png">    </p:cNvPr>
+          <p:cNvPicPr>
+            <a:picLocks noChangeAspect="1"/>
+          </p:cNvPicPr>
+          <p:nvPr/>
+        </p:nvPicPr>
+        <p:blipFill>
+          <a:blip r:embed="rId1"/>
+          <a:stretch>
+            <a:fillRect/>
+          </a:stretch>
+        </p:blipFill>
+        <p:spPr>
+          <a:xfrm>
+            <a:off x="548640" y="6419088"/>
+            <a:ext cx="274320" cy="274320"/>
+          </a:xfrm>
+          <a:prstGeom prst="rect">
+            <a:avLst/>
+          </a:prstGeom>
+        </p:spPr>
+      </p:pic>
+      <p:sp>
+        <p:nvSpPr>
+          <p:cNvPr id="4" name="Text 0"/>
           <p:cNvSpPr/>
           <p:nvPr/>
         </p:nvSpPr>
         <p:spPr>
           <a:xfrm>
-            <a:off x="548640" y="6446520"/>
+            <a:off x="896112" y="6446520"/>
             <a:ext cx="7315200" cy="274320"/>
           </a:xfrm>
           <a:prstGeom prst="rect">
@@ -4035,15 +4059,39 @@
           </a:p>
         </p:txBody>
       </p:sp>
-      <p:sp>
-        <p:nvSpPr>
-          <p:cNvPr id="3" name="Text 0"/>
+      <p:pic>
+        <p:nvPicPr>
+          <p:cNvPr id="3" name="Image 0" descr="/Users/manangilhotra010/Happiest Health HACK/TwinPulse_NewtonSchoolOfTechnology_RishihoodUniversity/docs/brand/nighttwin_logo.png">    </p:cNvPr>
+          <p:cNvPicPr>
+            <a:picLocks noChangeAspect="1"/>
+          </p:cNvPicPr>
+          <p:nvPr/>
+        </p:nvPicPr>
+        <p:blipFill>
+          <a:blip r:embed="rId1"/>
+          <a:stretch>
+            <a:fillRect/>
+          </a:stretch>
+        </p:blipFill>
+        <p:spPr>
+          <a:xfrm>
+            <a:off x="548640" y="6419088"/>
+            <a:ext cx="274320" cy="274320"/>
+          </a:xfrm>
+          <a:prstGeom prst="rect">
+            <a:avLst/>
+          </a:prstGeom>
+        </p:spPr>
+      </p:pic>
+      <p:sp>
+        <p:nvSpPr>
+          <p:cNvPr id="4" name="Text 0"/>
           <p:cNvSpPr/>
           <p:nvPr/>
         </p:nvSpPr>
         <p:spPr>
           <a:xfrm>
-            <a:off x="548640" y="6446520"/>
+            <a:off x="896112" y="6446520"/>
             <a:ext cx="7315200" cy="274320"/>
           </a:xfrm>
           <a:prstGeom prst="rect">
@@ -4466,9 +4514,33 @@
           <a:chExt cx="0" cy="0"/>
         </a:xfrm>
       </p:grpSpPr>
-      <p:sp>
-        <p:nvSpPr>
-          <p:cNvPr id="2" name="text-1"/>
+      <p:pic>
+        <p:nvPicPr>
+          <p:cNvPr id="2" name="logo-title" descr="NightTwin logo">    </p:cNvPr>
+          <p:cNvPicPr>
+            <a:picLocks noChangeAspect="1"/>
+          </p:cNvPicPr>
+          <p:nvPr/>
+        </p:nvPicPr>
+        <p:blipFill>
+          <a:blip r:embed="rId1"/>
+          <a:stretch>
+            <a:fillRect/>
+          </a:stretch>
+        </p:blipFill>
+        <p:spPr>
+          <a:xfrm>
+            <a:off x="640080" y="502920"/>
+            <a:ext cx="777240" cy="777240"/>
+          </a:xfrm>
+          <a:prstGeom prst="rect">
+            <a:avLst/>
+          </a:prstGeom>
+        </p:spPr>
+      </p:pic>
+      <p:sp>
+        <p:nvSpPr>
+          <p:cNvPr id="3" name="text-1"/>
           <p:cNvSpPr txBox="1"/>
           <p:nvPr/>
         </p:nvSpPr>
@@ -4504,7 +4576,7 @@
       </p:sp>
       <p:sp>
         <p:nvSpPr>
-          <p:cNvPr id="3" name="Text 0"/>
+          <p:cNvPr id="4" name="Text 0"/>
           <p:cNvSpPr/>
           <p:nvPr>
             <p:ph idx="100" type="title" hasCustomPrompt="1"/>
@@ -4545,7 +4617,7 @@
       </p:sp>
       <p:sp>
         <p:nvSpPr>
-          <p:cNvPr id="4" name="Text 0"/>
+          <p:cNvPr id="5" name="Text 0"/>
           <p:cNvSpPr/>
           <p:nvPr>
             <p:ph idx="101" type="body" hasCustomPrompt="1"/>
@@ -4583,7 +4655,7 @@
       </p:sp>
       <p:sp>
         <p:nvSpPr>
-          <p:cNvPr id="5" name="text-2"/>
+          <p:cNvPr id="6" name="text-2"/>
           <p:cNvSpPr txBox="1"/>
           <p:nvPr/>
         </p:nvSpPr>
@@ -4619,7 +4691,7 @@
       </p:sp>
       <p:sp>
         <p:nvSpPr>
-          <p:cNvPr id="6" name="text-3"/>
+          <p:cNvPr id="7" name="text-3"/>
           <p:cNvSpPr txBox="1"/>
           <p:nvPr/>
         </p:nvSpPr>
@@ -4655,7 +4727,7 @@
       </p:sp>
       <p:sp>
         <p:nvSpPr>
-          <p:cNvPr id="7" name="moon"/>
+          <p:cNvPr id="8" name="moon"/>
           <p:cNvSpPr/>
           <p:nvPr/>
         </p:nvSpPr>
@@ -4680,7 +4752,7 @@
       </p:sp>
       <p:sp>
         <p:nvSpPr>
-          <p:cNvPr id="8" name="moon-shadow"/>
+          <p:cNvPr id="9" name="moon-shadow"/>
           <p:cNvSpPr/>
           <p:nvPr/>
         </p:nvSpPr>
@@ -4705,7 +4777,7 @@
       </p:sp>
       <p:sp>
         <p:nvSpPr>
-          <p:cNvPr id="9" name="text-4"/>
+          <p:cNvPr id="10" name="text-4"/>
           <p:cNvSpPr txBox="1"/>
           <p:nvPr/>
         </p:nvSpPr>
@@ -5810,7 +5882,7 @@
         <p:spPr>
           <a:xfrm>
             <a:off x="548640" y="1234440"/>
-            <a:ext cx="6583680" cy="4681728"/>
+            <a:ext cx="6583680" cy="5023104"/>
           </a:xfrm>
           <a:prstGeom prst="rect">
             <a:avLst/>
@@ -8033,9 +8105,33 @@
           </a:p>
         </p:txBody>
       </p:sp>
-      <p:sp>
-        <p:nvSpPr>
-          <p:cNvPr id="3" name="Text 0"/>
+      <p:pic>
+        <p:nvPicPr>
+          <p:cNvPr id="3" name="logo-close" descr="NightTwin logo">    </p:cNvPr>
+          <p:cNvPicPr>
+            <a:picLocks noChangeAspect="1"/>
+          </p:cNvPicPr>
+          <p:nvPr/>
+        </p:nvPicPr>
+        <p:blipFill>
+          <a:blip r:embed="rId1"/>
+          <a:stretch>
+            <a:fillRect/>
+          </a:stretch>
+        </p:blipFill>
+        <p:spPr>
+          <a:xfrm>
+            <a:off x="640080" y="822960"/>
+            <a:ext cx="777240" cy="777240"/>
+          </a:xfrm>
+          <a:prstGeom prst="rect">
+            <a:avLst/>
+          </a:prstGeom>
+        </p:spPr>
+      </p:pic>
+      <p:sp>
+        <p:nvSpPr>
+          <p:cNvPr id="4" name="Text 0"/>
           <p:cNvSpPr/>
           <p:nvPr>
             <p:ph idx="101" type="body" hasCustomPrompt="1"/>
@@ -8073,7 +8169,7 @@
       </p:sp>
       <p:sp>
         <p:nvSpPr>
-          <p:cNvPr id="4" name="text-132"/>
+          <p:cNvPr id="5" name="text-132"/>
           <p:cNvSpPr txBox="1"/>
           <p:nvPr/>
         </p:nvSpPr>
@@ -8123,7 +8219,7 @@
       </p:sp>
       <p:sp>
         <p:nvSpPr>
-          <p:cNvPr id="5" name="text-133"/>
+          <p:cNvPr id="6" name="text-133"/>
           <p:cNvSpPr txBox="1"/>
           <p:nvPr/>
         </p:nvSpPr>
@@ -8159,7 +8255,7 @@
       </p:sp>
       <p:sp>
         <p:nvSpPr>
-          <p:cNvPr id="6" name="moon-close"/>
+          <p:cNvPr id="7" name="moon-close"/>
           <p:cNvSpPr/>
           <p:nvPr/>
         </p:nvSpPr>
@@ -8184,7 +8280,7 @@
       </p:sp>
       <p:sp>
         <p:nvSpPr>
-          <p:cNvPr id="7" name="moon-close-shadow"/>
+          <p:cNvPr id="8" name="moon-close-shadow"/>
           <p:cNvSpPr/>
           <p:nvPr/>
         </p:nvSpPr>

</xml_diff>

<commit_message>
Final jury video: hooks, neural voices, recorded live demo, captions; Manas Saxena as team leader
- scripts/video_script.py: opening and closing hooks, tighter script, on-screen action for every line
- scripts/make_video.py: edge-tts neural voices, Playwright/Chrome screencast with visible cursor,
  animated title and chapter cards, slide camera moves, burned-in captions, music bed
- README, deck and script list Manas Saxena as team leader
</commit_message>
<xml_diff>
--- a/docs/TwinPulse_Presentation.pptx
+++ b/docs/TwinPulse_Presentation.pptx
@@ -124,24 +124,24 @@
   <p:extLst>
     <p:ext uri="{521415D9-36F7-43E2-AB2F-B90AF26B5E84}">
       <p14:sectionLst xmlns:p14="http://schemas.microsoft.com/office/powerpoint/2010/main">
-        <p14:section name="Opening" id="{f4944502-0dcf-a543-b4c2-76da9721d6a7}">
+        <p14:section name="Opening" id="{3f0734b2-50d8-ddbb-f4f0-8067c74a1072}">
           <p14:sldIdLst>
             <p14:sldId id="256"/>
             <p14:sldId id="257"/>
           </p14:sldIdLst>
         </p14:section>
-        <p14:section name="Problem" id="{8221603f-7e8a-e776-2c38-45dd0be19cab}">
+        <p14:section name="Problem" id="{7656f35a-04f9-dd77-bd91-884c45065aec}">
           <p14:sldIdLst>
             <p14:sldId id="258"/>
           </p14:sldIdLst>
         </p14:section>
-        <p14:section name="Solution" id="{359636aa-4dee-40ee-468d-8f0e193dc70a}">
+        <p14:section name="Solution" id="{777c5b37-b646-67dd-2733-4892599ce18b}">
           <p14:sldIdLst>
             <p14:sldId id="259"/>
             <p14:sldId id="260"/>
           </p14:sldIdLst>
         </p14:section>
-        <p14:section name="How it works" id="{89ee4d2d-f961-698d-dfcd-aef78d22b26e}">
+        <p14:section name="How it works" id="{48474fc0-5aa4-b1e3-5a37-292a93767a9c}">
           <p14:sldIdLst>
             <p14:sldId id="261"/>
             <p14:sldId id="262"/>
@@ -149,27 +149,27 @@
             <p14:sldId id="264"/>
           </p14:sldIdLst>
         </p14:section>
-        <p14:section name="Evidence" id="{41c3631e-af68-db21-da4c-c459621a44dc}">
+        <p14:section name="Evidence" id="{87dbd459-dd3a-3af9-89da-25465ea26ffd}">
           <p14:sldIdLst>
             <p14:sldId id="265"/>
             <p14:sldId id="266"/>
             <p14:sldId id="267"/>
           </p14:sldIdLst>
         </p14:section>
-        <p14:section name="Product" id="{33b120f5-1613-a353-f81d-586dda12904a}">
+        <p14:section name="Product" id="{bb12f269-2274-7ef5-e9e4-2996c7c99c64}">
           <p14:sldIdLst>
             <p14:sldId id="268"/>
             <p14:sldId id="269"/>
           </p14:sldIdLst>
         </p14:section>
-        <p14:section name="Trust and impact" id="{21ec2651-577d-ef30-9b40-5b510f0c8a24}">
+        <p14:section name="Trust and impact" id="{34fdf6e3-2363-7ade-afc9-c31cf1173e93}">
           <p14:sldIdLst>
             <p14:sldId id="270"/>
             <p14:sldId id="271"/>
             <p14:sldId id="272"/>
           </p14:sldIdLst>
         </p14:section>
-        <p14:section name="Close" id="{4ef8ceae-aaf4-701e-a6d0-e6be6b4f94ff}">
+        <p14:section name="Close" id="{f00d6984-eea3-b3be-8b97-42cf989b7b96}">
           <p14:sldIdLst>
             <p14:sldId id="273"/>
           </p14:sldIdLst>
@@ -4719,7 +4719,7 @@
                   <a:schemeClr val="accent5"/>
                 </a:solidFill>
               </a:rPr>
-              <a:t>Manan Gilhotra (team leader) · Manas Saxena</a:t>
+              <a:t>Manas Saxena (team leader) · Manan Gilhotra</a:t>
             </a:r>
             <a:endParaRPr lang="en-US" sz="1400" dirty="0"/>
           </a:p>
@@ -8211,7 +8211,7 @@
                   <a:schemeClr val="bg1"/>
                 </a:solidFill>
               </a:rPr>
-              <a:t>Manan Gilhotra (team leader) · Manas Saxena</a:t>
+              <a:t>Manas Saxena (team leader) · Manan Gilhotra</a:t>
             </a:r>
             <a:endParaRPr lang="en-US" sz="1600" dirty="0"/>
           </a:p>

</xml_diff>